<commit_message>
Update readme & report
</commit_message>
<xml_diff>
--- a/report/113598101_SSRE_report.pptx
+++ b/report/113598101_SSRE_report.pptx
@@ -6031,6 +6031,7 @@
               </a:defRPr>
             </a:pPr>
             <a:r>
+              <a:rPr dirty="0"/>
               <a:t>Test Suite Execution</a:t>
             </a:r>
           </a:p>
@@ -6044,8 +6045,8 @@
         </p:nvSpPr>
         <p:spPr>
           <a:xfrm>
-            <a:off x="457200" y="1554480"/>
-            <a:ext cx="4572000" cy="457200"/>
+            <a:off x="457200" y="1629190"/>
+            <a:ext cx="3068537" cy="317837"/>
           </a:xfrm>
           <a:prstGeom prst="roundRect">
             <a:avLst/>
@@ -6113,8 +6114,12 @@
               </a:defRPr>
             </a:pPr>
             <a:r>
+              <a:rPr b="1" dirty="0"/>
+              <a:t>python</a:t>
+            </a:r>
+            <a:r>
               <a:rPr dirty="0"/>
-              <a:t>python -m </a:t>
+              <a:t> -m </a:t>
             </a:r>
             <a:r>
               <a:rPr dirty="0" err="1"/>
@@ -8401,7 +8406,7 @@
         <p:spPr>
           <a:xfrm>
             <a:off x="3540807" y="2921168"/>
-            <a:ext cx="5110079" cy="1015663"/>
+            <a:ext cx="5110079" cy="769441"/>
           </a:xfrm>
           <a:prstGeom prst="rect">
             <a:avLst/>
@@ -8422,14 +8427,14 @@
               </a:defRPr>
             </a:pPr>
             <a:r>
-              <a:rPr lang="en-US" altLang="zh-TW" sz="6000" dirty="0"/>
+              <a:rPr lang="en-US" altLang="zh-TW" sz="4400" dirty="0"/>
               <a:t>Thank You !</a:t>
             </a:r>
             <a:r>
-              <a:rPr lang="zh-TW" altLang="en-US" sz="6000" dirty="0"/>
+              <a:rPr lang="zh-TW" altLang="en-US" sz="4400" dirty="0"/>
               <a:t>🎉</a:t>
             </a:r>
-            <a:endParaRPr sz="6000" dirty="0"/>
+            <a:endParaRPr sz="4400" dirty="0"/>
           </a:p>
         </p:txBody>
       </p:sp>

</xml_diff>